<commit_message>
Draw the PPT charts as images so they show in every viewer instead of relying on PowerPoint-native charts, and fix the label overlap on the category chart.
</commit_message>
<xml_diff>
--- a/dashboard/public/reports/Auto_Parts_Price_Outlook.pptx
+++ b/dashboard/public/reports/Auto_Parts_Price_Outlook.pptx
@@ -114,1735 +114,6 @@
     </a:lvl9pPr>
   </p:defaultTextStyle>
 </p:presentation>
-</file>
-
-<file path=ppt/charts/chart1.xml><?xml version="1.0" encoding="utf-8"?>
-<c:chartSpace xmlns:c="http://schemas.openxmlformats.org/drawingml/2006/chart" xmlns:a="http://schemas.openxmlformats.org/drawingml/2006/main" xmlns:r="http://schemas.openxmlformats.org/officeDocument/2006/relationships">
-  <c:date1904 val="0"/>
-  <c:roundedCorners val="1"/>
-  <c:chart>
-    <c:autoTitleDeleted val="1"/>
-    <c:plotArea>
-      <c:layout/>
-      <c:lineChart>
-        <c:varyColors val="0"/>
-        <c:ser>
-          <c:idx val="0"/>
-          <c:order val="0"/>
-          <c:tx>
-            <c:strRef>
-              <c:f>Sheet1!$B$1</c:f>
-              <c:strCache>
-                <c:ptCount val="1"/>
-                <c:pt idx="0">
-                  <c:v>Forecast</c:v>
-                </c:pt>
-              </c:strCache>
-            </c:strRef>
-          </c:tx>
-          <c:spPr>
-            <a:solidFill>
-              <a:srgbClr val="2563EB"/>
-            </a:solidFill>
-            <a:ln w="38100" cap="flat">
-              <a:solidFill>
-                <a:srgbClr val="2563EB"/>
-              </a:solidFill>
-              <a:prstDash val="solid"/>
-              <a:round/>
-            </a:ln>
-            <a:effectLst/>
-          </c:spPr>
-          <c:invertIfNegative val="0"/>
-          <c:dLbls>
-            <c:numFmt formatCode="0.00" sourceLinked="0"/>
-            <c:txPr>
-              <a:bodyPr/>
-              <a:lstStyle/>
-              <a:p>
-                <a:pPr>
-                  <a:defRPr b="0" i="0" strike="noStrike" sz="1100" u="none">
-                    <a:solidFill>
-                      <a:srgbClr val="1E293B"/>
-                    </a:solidFill>
-                    <a:latin typeface="Arial"/>
-                  </a:defRPr>
-                </a:pPr>
-              </a:p>
-            </c:txPr>
-            <c:dLblPos val="t"/>
-            <c:showLegendKey val="0"/>
-            <c:showVal val="1"/>
-            <c:showCatName val="0"/>
-            <c:showSerName val="0"/>
-            <c:showPercent val="0"/>
-            <c:showBubbleSize val="0"/>
-            <c:showLeaderLines val="0"/>
-          </c:dLbls>
-          <c:marker>
-            <c:symbol val="circle"/>
-            <c:size val="8"/>
-            <c:spPr>
-              <a:solidFill>
-                <a:srgbClr val="2563EB"/>
-              </a:solidFill>
-              <a:ln w="9525" cap="flat">
-                <a:solidFill>
-                  <a:srgbClr val="2563EB"/>
-                </a:solidFill>
-                <a:prstDash val="solid"/>
-                <a:round/>
-              </a:ln>
-              <a:effectLst/>
-            </c:spPr>
-          </c:marker>
-          <c:cat>
-            <c:multiLvlStrRef>
-              <c:f>Sheet1!$A$2:$A$7</c:f>
-              <c:multiLvlStrCache>
-                <c:ptCount val="6"/>
-                <c:lvl>
-                  <c:pt idx="0">
-                    <c:v>Jul</c:v>
-                  </c:pt>
-                  <c:pt idx="1">
-                    <c:v>Aug</c:v>
-                  </c:pt>
-                  <c:pt idx="2">
-                    <c:v>Sep</c:v>
-                  </c:pt>
-                  <c:pt idx="3">
-                    <c:v>Oct</c:v>
-                  </c:pt>
-                  <c:pt idx="4">
-                    <c:v>Nov</c:v>
-                  </c:pt>
-                  <c:pt idx="5">
-                    <c:v>Dec</c:v>
-                  </c:pt>
-                </c:lvl>
-              </c:multiLvlStrCache>
-            </c:multiLvlStrRef>
-          </c:cat>
-          <c:val>
-            <c:numRef>
-              <c:f>Sheet1!$B$2:$B$7</c:f>
-              <c:numCache>
-                <c:formatCode>General</c:formatCode>
-                <c:ptCount val="6"/>
-                <c:pt idx="0">
-                  <c:v>17.7</c:v>
-                </c:pt>
-                <c:pt idx="1">
-                  <c:v>17.58</c:v>
-                </c:pt>
-                <c:pt idx="2">
-                  <c:v>17.82</c:v>
-                </c:pt>
-                <c:pt idx="3">
-                  <c:v>17.93</c:v>
-                </c:pt>
-                <c:pt idx="4">
-                  <c:v>17.81</c:v>
-                </c:pt>
-                <c:pt idx="5">
-                  <c:v>17.78</c:v>
-                </c:pt>
-              </c:numCache>
-            </c:numRef>
-          </c:val>
-          <c:smooth val="0"/>
-        </c:ser>
-        <c:dLbls>
-          <c:numFmt formatCode="0.00" sourceLinked="0"/>
-          <c:txPr>
-            <a:bodyPr/>
-            <a:lstStyle/>
-            <a:p>
-              <a:pPr>
-                <a:defRPr b="0" i="0" strike="noStrike" sz="1100" u="none">
-                  <a:solidFill>
-                    <a:srgbClr val="1E293B"/>
-                  </a:solidFill>
-                  <a:latin typeface="Arial"/>
-                </a:defRPr>
-              </a:pPr>
-            </a:p>
-          </c:txPr>
-          <c:dLblPos val="t"/>
-          <c:showLegendKey val="0"/>
-          <c:showVal val="1"/>
-          <c:showCatName val="0"/>
-          <c:showSerName val="0"/>
-          <c:showPercent val="0"/>
-          <c:showBubbleSize val="0"/>
-          <c:showLeaderLines val="0"/>
-        </c:dLbls>
-        <c:marker val="1"/>
-        <c:axId val="2094734554"/>
-        <c:axId val="2094734552"/>
-        <c:axId val="2094734556"/>
-      </c:lineChart>
-      <c:catAx>
-        <c:axId val="2094734554"/>
-        <c:scaling>
-          <c:orientation val="minMax"/>
-        </c:scaling>
-        <c:delete val="0"/>
-        <c:axPos val="b"/>
-        <c:numFmt formatCode="General" sourceLinked="1"/>
-        <c:majorTickMark val="out"/>
-        <c:minorTickMark val="none"/>
-        <c:tickLblPos val="low"/>
-        <c:spPr>
-          <a:ln w="12700" cap="flat">
-            <a:solidFill>
-              <a:srgbClr val="888888"/>
-            </a:solidFill>
-            <a:prstDash val="solid"/>
-            <a:round/>
-          </a:ln>
-        </c:spPr>
-        <c:txPr>
-          <a:bodyPr/>
-          <a:lstStyle/>
-          <a:p>
-            <a:pPr>
-              <a:defRPr sz="1100" b="0" i="0" u="none" strike="noStrike">
-                <a:solidFill>
-                  <a:srgbClr val="64748B"/>
-                </a:solidFill>
-                <a:latin typeface="Arial"/>
-              </a:defRPr>
-            </a:pPr>
-            <a:endParaRPr lang="en-US"/>
-          </a:p>
-        </c:txPr>
-        <c:crossAx val="2094734552"/>
-        <c:crosses val="autoZero"/>
-        <c:auto val="1"/>
-        <c:lblAlgn val="ctr"/>
-        <c:noMultiLvlLbl val="1"/>
-      </c:catAx>
-      <c:valAx>
-        <c:axId val="2094734552"/>
-        <c:scaling>
-          <c:orientation val="minMax"/>
-          <c:max val="18.1"/>
-          <c:min val="17.4"/>
-        </c:scaling>
-        <c:delete val="0"/>
-        <c:axPos val="l"/>
-        <c:majorGridlines>
-          <c:spPr>
-            <a:ln w="6350" cap="flat">
-              <a:solidFill>
-                <a:srgbClr val="E2E8F0"/>
-              </a:solidFill>
-              <a:prstDash val="solid"/>
-              <a:round/>
-            </a:ln>
-          </c:spPr>
-        </c:majorGridlines>
-        <c:numFmt formatCode="General" sourceLinked="0"/>
-        <c:majorTickMark val="out"/>
-        <c:minorTickMark val="none"/>
-        <c:tickLblPos val="nextTo"/>
-        <c:spPr>
-          <a:ln w="12700" cap="flat">
-            <a:solidFill>
-              <a:srgbClr val="888888"/>
-            </a:solidFill>
-            <a:prstDash val="solid"/>
-            <a:round/>
-          </a:ln>
-        </c:spPr>
-        <c:txPr>
-          <a:bodyPr/>
-          <a:lstStyle/>
-          <a:p>
-            <a:pPr>
-              <a:defRPr sz="1100" b="0" i="0" u="none" strike="noStrike">
-                <a:solidFill>
-                  <a:srgbClr val="64748B"/>
-                </a:solidFill>
-                <a:latin typeface="Arial"/>
-              </a:defRPr>
-            </a:pPr>
-            <a:endParaRPr lang="en-US"/>
-          </a:p>
-        </c:txPr>
-        <c:crossAx val="2094734554"/>
-        <c:crosses val="autoZero"/>
-        <c:crossBetween val="between"/>
-      </c:valAx>
-      <c:spPr>
-        <a:noFill/>
-        <a:ln>
-          <a:noFill/>
-        </a:ln>
-        <a:effectLst/>
-      </c:spPr>
-    </c:plotArea>
-    <c:plotVisOnly val="1"/>
-    <c:dispBlanksAs val="span"/>
-  </c:chart>
-  <c:spPr>
-    <a:noFill/>
-    <a:ln>
-      <a:noFill/>
-    </a:ln>
-    <a:effectLst/>
-  </c:spPr>
-  <c:externalData r:id="rId1">
-    <c:autoUpdate val="0"/>
-  </c:externalData>
-</c:chartSpace>
-</file>
-
-<file path=ppt/charts/chart2.xml><?xml version="1.0" encoding="utf-8"?>
-<c:chartSpace xmlns:c="http://schemas.openxmlformats.org/drawingml/2006/chart" xmlns:a="http://schemas.openxmlformats.org/drawingml/2006/main" xmlns:r="http://schemas.openxmlformats.org/officeDocument/2006/relationships">
-  <c:date1904 val="0"/>
-  <c:roundedCorners val="1"/>
-  <c:chart>
-    <c:autoTitleDeleted val="1"/>
-    <c:plotArea>
-      <c:layout/>
-      <c:barChart>
-        <c:barDir val="bar"/>
-        <c:grouping val="clustered"/>
-        <c:varyColors val="0"/>
-        <c:ser>
-          <c:idx val="0"/>
-          <c:order val="0"/>
-          <c:tx>
-            <c:strRef>
-              <c:f>Sheet1!$B$1</c:f>
-              <c:strCache>
-                <c:ptCount val="1"/>
-                <c:pt idx="0">
-                  <c:v>Change %</c:v>
-                </c:pt>
-              </c:strCache>
-            </c:strRef>
-          </c:tx>
-          <c:spPr>
-            <a:solidFill>
-              <a:srgbClr val="2563EB"/>
-            </a:solidFill>
-            <a:effectLst/>
-          </c:spPr>
-          <c:invertIfNegative val="0"/>
-          <c:dLbls>
-            <c:numFmt formatCode="0.0" sourceLinked="0"/>
-            <c:txPr>
-              <a:bodyPr/>
-              <a:lstStyle/>
-              <a:p>
-                <a:pPr>
-                  <a:defRPr b="0" i="0" strike="noStrike" sz="1100" u="none">
-                    <a:solidFill>
-                      <a:srgbClr val="1E293B"/>
-                    </a:solidFill>
-                    <a:latin typeface="Arial"/>
-                  </a:defRPr>
-                </a:pPr>
-              </a:p>
-            </c:txPr>
-            <c:showLegendKey val="0"/>
-            <c:showVal val="1"/>
-            <c:showCatName val="0"/>
-            <c:showSerName val="0"/>
-            <c:showPercent val="0"/>
-            <c:showBubbleSize val="0"/>
-            <c:showLeaderLines val="0"/>
-          </c:dLbls>
-          <c:dPt>
-            <c:idx val="0"/>
-            <c:invertIfNegative val="0"/>
-            <c:bubble3D val="0"/>
-            <c:spPr>
-              <a:solidFill>
-                <a:srgbClr val="2563EB"/>
-              </a:solidFill>
-              <a:effectLst/>
-            </c:spPr>
-          </c:dPt>
-          <c:dPt>
-            <c:idx val="1"/>
-            <c:invertIfNegative val="0"/>
-            <c:bubble3D val="0"/>
-            <c:spPr>
-              <a:solidFill>
-                <a:srgbClr val="2563EB"/>
-              </a:solidFill>
-              <a:effectLst/>
-            </c:spPr>
-          </c:dPt>
-          <c:dPt>
-            <c:idx val="2"/>
-            <c:invertIfNegative val="0"/>
-            <c:bubble3D val="0"/>
-            <c:spPr>
-              <a:solidFill>
-                <a:srgbClr val="2563EB"/>
-              </a:solidFill>
-              <a:effectLst/>
-            </c:spPr>
-          </c:dPt>
-          <c:dPt>
-            <c:idx val="3"/>
-            <c:invertIfNegative val="0"/>
-            <c:bubble3D val="0"/>
-            <c:spPr>
-              <a:solidFill>
-                <a:srgbClr val="2563EB"/>
-              </a:solidFill>
-              <a:effectLst/>
-            </c:spPr>
-          </c:dPt>
-          <c:dPt>
-            <c:idx val="4"/>
-            <c:invertIfNegative val="0"/>
-            <c:bubble3D val="0"/>
-            <c:spPr>
-              <a:solidFill>
-                <a:srgbClr val="2563EB"/>
-              </a:solidFill>
-              <a:effectLst/>
-            </c:spPr>
-          </c:dPt>
-          <c:dPt>
-            <c:idx val="5"/>
-            <c:invertIfNegative val="0"/>
-            <c:bubble3D val="0"/>
-            <c:spPr>
-              <a:solidFill>
-                <a:srgbClr val="2563EB"/>
-              </a:solidFill>
-              <a:effectLst/>
-            </c:spPr>
-          </c:dPt>
-          <c:dPt>
-            <c:idx val="6"/>
-            <c:invertIfNegative val="0"/>
-            <c:bubble3D val="0"/>
-            <c:spPr>
-              <a:solidFill>
-                <a:srgbClr val="2563EB"/>
-              </a:solidFill>
-              <a:effectLst/>
-            </c:spPr>
-          </c:dPt>
-          <c:dPt>
-            <c:idx val="7"/>
-            <c:invertIfNegative val="0"/>
-            <c:bubble3D val="0"/>
-            <c:spPr>
-              <a:solidFill>
-                <a:srgbClr val="2563EB"/>
-              </a:solidFill>
-              <a:effectLst/>
-            </c:spPr>
-          </c:dPt>
-          <c:dPt>
-            <c:idx val="8"/>
-            <c:invertIfNegative val="0"/>
-            <c:bubble3D val="0"/>
-            <c:spPr>
-              <a:solidFill>
-                <a:srgbClr val="16A34A"/>
-              </a:solidFill>
-              <a:effectLst/>
-            </c:spPr>
-          </c:dPt>
-          <c:dPt>
-            <c:idx val="9"/>
-            <c:invertIfNegative val="0"/>
-            <c:bubble3D val="0"/>
-            <c:spPr>
-              <a:solidFill>
-                <a:srgbClr val="16A34A"/>
-              </a:solidFill>
-              <a:effectLst/>
-            </c:spPr>
-          </c:dPt>
-          <c:cat>
-            <c:multiLvlStrRef>
-              <c:f>Sheet1!$A$2:$A$11</c:f>
-              <c:multiLvlStrCache>
-                <c:ptCount val="10"/>
-                <c:lvl>
-                  <c:pt idx="0">
-                    <c:v>Electrical</c:v>
-                  </c:pt>
-                  <c:pt idx="1">
-                    <c:v>Lighting</c:v>
-                  </c:pt>
-                  <c:pt idx="2">
-                    <c:v>Chassis</c:v>
-                  </c:pt>
-                  <c:pt idx="3">
-                    <c:v>Braking</c:v>
-                  </c:pt>
-                  <c:pt idx="4">
-                    <c:v>Body Stampings</c:v>
-                  </c:pt>
-                  <c:pt idx="5">
-                    <c:v>Fasteners</c:v>
-                  </c:pt>
-                  <c:pt idx="6">
-                    <c:v>Interior Trim</c:v>
-                  </c:pt>
-                  <c:pt idx="7">
-                    <c:v>Sensors</c:v>
-                  </c:pt>
-                  <c:pt idx="8">
-                    <c:v>Powertrain</c:v>
-                  </c:pt>
-                  <c:pt idx="9">
-                    <c:v>HVAC</c:v>
-                  </c:pt>
-                </c:lvl>
-              </c:multiLvlStrCache>
-            </c:multiLvlStrRef>
-          </c:cat>
-          <c:val>
-            <c:numRef>
-              <c:f>Sheet1!$B$2:$B$11</c:f>
-              <c:numCache>
-                <c:formatCode>General</c:formatCode>
-                <c:ptCount val="10"/>
-                <c:pt idx="0">
-                  <c:v>6.84</c:v>
-                </c:pt>
-                <c:pt idx="1">
-                  <c:v>5.1</c:v>
-                </c:pt>
-                <c:pt idx="2">
-                  <c:v>3.07</c:v>
-                </c:pt>
-                <c:pt idx="3">
-                  <c:v>2.47</c:v>
-                </c:pt>
-                <c:pt idx="4">
-                  <c:v>2.11</c:v>
-                </c:pt>
-                <c:pt idx="5">
-                  <c:v>1.82</c:v>
-                </c:pt>
-                <c:pt idx="6">
-                  <c:v>0.62</c:v>
-                </c:pt>
-                <c:pt idx="7">
-                  <c:v>0.13</c:v>
-                </c:pt>
-                <c:pt idx="8">
-                  <c:v>-0.32</c:v>
-                </c:pt>
-                <c:pt idx="9">
-                  <c:v>-2.9</c:v>
-                </c:pt>
-              </c:numCache>
-            </c:numRef>
-          </c:val>
-        </c:ser>
-        <c:dLbls>
-          <c:numFmt formatCode="0.0" sourceLinked="0"/>
-          <c:txPr>
-            <a:bodyPr/>
-            <a:lstStyle/>
-            <a:p>
-              <a:pPr>
-                <a:defRPr b="0" i="0" strike="noStrike" sz="1100" u="none">
-                  <a:solidFill>
-                    <a:srgbClr val="1E293B"/>
-                  </a:solidFill>
-                  <a:latin typeface="Arial"/>
-                </a:defRPr>
-              </a:pPr>
-            </a:p>
-          </c:txPr>
-          <c:showLegendKey val="0"/>
-          <c:showVal val="1"/>
-          <c:showCatName val="0"/>
-          <c:showSerName val="0"/>
-          <c:showPercent val="0"/>
-          <c:showBubbleSize val="0"/>
-          <c:showLeaderLines val="0"/>
-        </c:dLbls>
-        <c:gapWidth val="150"/>
-        <c:overlap val="0"/>
-        <c:axId val="2094734554"/>
-        <c:axId val="2094734552"/>
-        <c:axId val="2094734556"/>
-      </c:barChart>
-      <c:catAx>
-        <c:axId val="2094734554"/>
-        <c:scaling>
-          <c:orientation val="maxMin"/>
-        </c:scaling>
-        <c:delete val="0"/>
-        <c:axPos val="l"/>
-        <c:numFmt formatCode="General" sourceLinked="1"/>
-        <c:majorTickMark val="out"/>
-        <c:minorTickMark val="none"/>
-        <c:tickLblPos val="nextTo"/>
-        <c:spPr>
-          <a:ln w="12700" cap="flat">
-            <a:solidFill>
-              <a:srgbClr val="888888"/>
-            </a:solidFill>
-            <a:prstDash val="solid"/>
-            <a:round/>
-          </a:ln>
-        </c:spPr>
-        <c:txPr>
-          <a:bodyPr/>
-          <a:lstStyle/>
-          <a:p>
-            <a:pPr>
-              <a:defRPr sz="1100" b="0" i="0" u="none" strike="noStrike">
-                <a:solidFill>
-                  <a:srgbClr val="1E293B"/>
-                </a:solidFill>
-                <a:latin typeface="Arial"/>
-              </a:defRPr>
-            </a:pPr>
-            <a:endParaRPr lang="en-US"/>
-          </a:p>
-        </c:txPr>
-        <c:crossAx val="2094734552"/>
-        <c:crosses val="autoZero"/>
-        <c:auto val="1"/>
-        <c:lblAlgn val="ctr"/>
-        <c:noMultiLvlLbl val="1"/>
-      </c:catAx>
-      <c:valAx>
-        <c:axId val="2094734552"/>
-        <c:scaling>
-          <c:orientation val="minMax"/>
-        </c:scaling>
-        <c:delete val="1"/>
-        <c:axPos val="b"/>
-        <c:majorGridlines>
-          <c:spPr>
-            <a:ln w="6350" cap="flat">
-              <a:solidFill>
-                <a:srgbClr val="E2E8F0"/>
-              </a:solidFill>
-              <a:prstDash val="solid"/>
-              <a:round/>
-            </a:ln>
-          </c:spPr>
-        </c:majorGridlines>
-        <c:numFmt formatCode="General" sourceLinked="0"/>
-        <c:majorTickMark val="out"/>
-        <c:minorTickMark val="none"/>
-        <c:tickLblPos val="low"/>
-        <c:spPr>
-          <a:ln w="12700" cap="flat">
-            <a:solidFill>
-              <a:srgbClr val="888888"/>
-            </a:solidFill>
-            <a:prstDash val="solid"/>
-            <a:round/>
-          </a:ln>
-        </c:spPr>
-        <c:txPr>
-          <a:bodyPr/>
-          <a:lstStyle/>
-          <a:p>
-            <a:pPr>
-              <a:defRPr sz="1100" b="0" i="0" u="none" strike="noStrike">
-                <a:solidFill>
-                  <a:srgbClr val="64748B"/>
-                </a:solidFill>
-                <a:latin typeface="Arial"/>
-              </a:defRPr>
-            </a:pPr>
-            <a:endParaRPr lang="en-US"/>
-          </a:p>
-        </c:txPr>
-        <c:crossAx val="2094734554"/>
-        <c:crosses val="autoZero"/>
-        <c:crossBetween val="between"/>
-      </c:valAx>
-      <c:spPr>
-        <a:noFill/>
-        <a:ln>
-          <a:noFill/>
-        </a:ln>
-        <a:effectLst/>
-      </c:spPr>
-    </c:plotArea>
-    <c:plotVisOnly val="1"/>
-    <c:dispBlanksAs val="span"/>
-  </c:chart>
-  <c:spPr>
-    <a:noFill/>
-    <a:ln>
-      <a:noFill/>
-    </a:ln>
-    <a:effectLst/>
-  </c:spPr>
-  <c:externalData r:id="rId1">
-    <c:autoUpdate val="0"/>
-  </c:externalData>
-</c:chartSpace>
-</file>
-
-<file path=ppt/charts/chart3.xml><?xml version="1.0" encoding="utf-8"?>
-<c:chartSpace xmlns:c="http://schemas.openxmlformats.org/drawingml/2006/chart" xmlns:a="http://schemas.openxmlformats.org/drawingml/2006/main" xmlns:r="http://schemas.openxmlformats.org/officeDocument/2006/relationships">
-  <c:date1904 val="0"/>
-  <c:roundedCorners val="1"/>
-  <c:chart>
-    <c:autoTitleDeleted val="1"/>
-    <c:plotArea>
-      <c:layout/>
-      <c:doughnutChart>
-        <c:varyColors val="1"/>
-        <c:ser>
-          <c:idx val="0"/>
-          <c:order val="0"/>
-          <c:tx>
-            <c:strRef>
-              <c:f>Sheet1!$B$1</c:f>
-              <c:strCache>
-                <c:ptCount val="1"/>
-                <c:pt idx="0">
-                  <c:v>Share</c:v>
-                </c:pt>
-              </c:strCache>
-            </c:strRef>
-          </c:tx>
-          <c:spPr>
-            <a:solidFill>
-              <a:schemeClr val="accent1"/>
-            </a:solidFill>
-            <a:ln w="9525" cap="flat">
-              <a:solidFill>
-                <a:srgbClr val="F9F9F9"/>
-              </a:solidFill>
-              <a:prstDash val="solid"/>
-              <a:round/>
-            </a:ln>
-            <a:effectLst/>
-          </c:spPr>
-          <c:dPt>
-            <c:idx val="0"/>
-            <c:bubble3D val="0"/>
-            <c:spPr>
-              <a:solidFill>
-                <a:srgbClr val="0B1F3A"/>
-              </a:solidFill>
-              <a:ln w="12700" cap="flat">
-                <a:solidFill>
-                  <a:srgbClr val="FFFFFF"/>
-                </a:solidFill>
-                <a:prstDash val="solid"/>
-                <a:round/>
-              </a:ln>
-              <a:effectLst/>
-            </c:spPr>
-          </c:dPt>
-          <c:dPt>
-            <c:idx val="1"/>
-            <c:bubble3D val="0"/>
-            <c:spPr>
-              <a:solidFill>
-                <a:srgbClr val="2563EB"/>
-              </a:solidFill>
-              <a:ln w="12700" cap="flat">
-                <a:solidFill>
-                  <a:srgbClr val="FFFFFF"/>
-                </a:solidFill>
-                <a:prstDash val="solid"/>
-                <a:round/>
-              </a:ln>
-              <a:effectLst/>
-            </c:spPr>
-          </c:dPt>
-          <c:dPt>
-            <c:idx val="2"/>
-            <c:bubble3D val="0"/>
-            <c:spPr>
-              <a:solidFill>
-                <a:srgbClr val="60A5FA"/>
-              </a:solidFill>
-              <a:ln w="12700" cap="flat">
-                <a:solidFill>
-                  <a:srgbClr val="FFFFFF"/>
-                </a:solidFill>
-                <a:prstDash val="solid"/>
-                <a:round/>
-              </a:ln>
-              <a:effectLst/>
-            </c:spPr>
-          </c:dPt>
-          <c:dPt>
-            <c:idx val="3"/>
-            <c:bubble3D val="0"/>
-            <c:spPr>
-              <a:solidFill>
-                <a:srgbClr val="93C5FD"/>
-              </a:solidFill>
-              <a:ln w="12700" cap="flat">
-                <a:solidFill>
-                  <a:srgbClr val="FFFFFF"/>
-                </a:solidFill>
-                <a:prstDash val="solid"/>
-                <a:round/>
-              </a:ln>
-              <a:effectLst/>
-            </c:spPr>
-          </c:dPt>
-          <c:dPt>
-            <c:idx val="4"/>
-            <c:bubble3D val="0"/>
-            <c:spPr>
-              <a:solidFill>
-                <a:srgbClr val="F59E0B"/>
-              </a:solidFill>
-              <a:ln w="12700" cap="flat">
-                <a:solidFill>
-                  <a:srgbClr val="FFFFFF"/>
-                </a:solidFill>
-                <a:prstDash val="solid"/>
-                <a:round/>
-              </a:ln>
-              <a:effectLst/>
-            </c:spPr>
-          </c:dPt>
-          <c:dPt>
-            <c:idx val="5"/>
-            <c:bubble3D val="0"/>
-            <c:spPr>
-              <a:solidFill>
-                <a:srgbClr val="94A3B8"/>
-              </a:solidFill>
-              <a:ln w="12700" cap="flat">
-                <a:solidFill>
-                  <a:srgbClr val="FFFFFF"/>
-                </a:solidFill>
-                <a:prstDash val="solid"/>
-                <a:round/>
-              </a:ln>
-              <a:effectLst/>
-            </c:spPr>
-          </c:dPt>
-          <c:dPt>
-            <c:idx val="6"/>
-            <c:bubble3D val="0"/>
-            <c:spPr>
-              <a:solidFill>
-                <a:srgbClr val="CBD5E1"/>
-              </a:solidFill>
-              <a:ln w="12700" cap="flat">
-                <a:solidFill>
-                  <a:srgbClr val="FFFFFF"/>
-                </a:solidFill>
-                <a:prstDash val="solid"/>
-                <a:round/>
-              </a:ln>
-              <a:effectLst/>
-            </c:spPr>
-          </c:dPt>
-          <c:dLbls>
-            <c:dLbl>
-              <c:idx val="0"/>
-              <c:numFmt formatCode="General" sourceLinked="0"/>
-              <c:spPr/>
-              <c:txPr>
-                <a:bodyPr/>
-                <a:lstStyle/>
-                <a:p>
-                  <a:pPr>
-                    <a:defRPr sz="1200" b="0" i="0" u="none" strike="noStrike">
-                      <a:solidFill>
-                        <a:srgbClr val="000000"/>
-                      </a:solidFill>
-                      <a:latin typeface="Arial"/>
-                    </a:defRPr>
-                  </a:pPr>
-                </a:p>
-              </c:txPr>
-              <c:showLegendKey val="0"/>
-              <c:showVal val="0"/>
-              <c:showCatName val="0"/>
-              <c:showSerName val="0"/>
-              <c:showPercent val="0"/>
-              <c:showBubbleSize val="0"/>
-            </c:dLbl>
-            <c:dLbl>
-              <c:idx val="1"/>
-              <c:numFmt formatCode="General" sourceLinked="0"/>
-              <c:spPr/>
-              <c:txPr>
-                <a:bodyPr/>
-                <a:lstStyle/>
-                <a:p>
-                  <a:pPr>
-                    <a:defRPr sz="1200" b="0" i="0" u="none" strike="noStrike">
-                      <a:solidFill>
-                        <a:srgbClr val="000000"/>
-                      </a:solidFill>
-                      <a:latin typeface="Arial"/>
-                    </a:defRPr>
-                  </a:pPr>
-                </a:p>
-              </c:txPr>
-              <c:showLegendKey val="0"/>
-              <c:showVal val="0"/>
-              <c:showCatName val="0"/>
-              <c:showSerName val="0"/>
-              <c:showPercent val="0"/>
-              <c:showBubbleSize val="0"/>
-            </c:dLbl>
-            <c:dLbl>
-              <c:idx val="2"/>
-              <c:numFmt formatCode="General" sourceLinked="0"/>
-              <c:spPr/>
-              <c:txPr>
-                <a:bodyPr/>
-                <a:lstStyle/>
-                <a:p>
-                  <a:pPr>
-                    <a:defRPr sz="1200" b="0" i="0" u="none" strike="noStrike">
-                      <a:solidFill>
-                        <a:srgbClr val="000000"/>
-                      </a:solidFill>
-                      <a:latin typeface="Arial"/>
-                    </a:defRPr>
-                  </a:pPr>
-                </a:p>
-              </c:txPr>
-              <c:showLegendKey val="0"/>
-              <c:showVal val="0"/>
-              <c:showCatName val="0"/>
-              <c:showSerName val="0"/>
-              <c:showPercent val="0"/>
-              <c:showBubbleSize val="0"/>
-            </c:dLbl>
-            <c:dLbl>
-              <c:idx val="3"/>
-              <c:numFmt formatCode="General" sourceLinked="0"/>
-              <c:spPr/>
-              <c:txPr>
-                <a:bodyPr/>
-                <a:lstStyle/>
-                <a:p>
-                  <a:pPr>
-                    <a:defRPr sz="1200" b="0" i="0" u="none" strike="noStrike">
-                      <a:solidFill>
-                        <a:srgbClr val="000000"/>
-                      </a:solidFill>
-                      <a:latin typeface="Arial"/>
-                    </a:defRPr>
-                  </a:pPr>
-                </a:p>
-              </c:txPr>
-              <c:showLegendKey val="0"/>
-              <c:showVal val="0"/>
-              <c:showCatName val="0"/>
-              <c:showSerName val="0"/>
-              <c:showPercent val="0"/>
-              <c:showBubbleSize val="0"/>
-            </c:dLbl>
-            <c:dLbl>
-              <c:idx val="4"/>
-              <c:numFmt formatCode="General" sourceLinked="0"/>
-              <c:spPr/>
-              <c:txPr>
-                <a:bodyPr/>
-                <a:lstStyle/>
-                <a:p>
-                  <a:pPr>
-                    <a:defRPr sz="1200" b="0" i="0" u="none" strike="noStrike">
-                      <a:solidFill>
-                        <a:srgbClr val="000000"/>
-                      </a:solidFill>
-                      <a:latin typeface="Arial"/>
-                    </a:defRPr>
-                  </a:pPr>
-                </a:p>
-              </c:txPr>
-              <c:showLegendKey val="0"/>
-              <c:showVal val="0"/>
-              <c:showCatName val="0"/>
-              <c:showSerName val="0"/>
-              <c:showPercent val="0"/>
-              <c:showBubbleSize val="0"/>
-            </c:dLbl>
-            <c:dLbl>
-              <c:idx val="5"/>
-              <c:numFmt formatCode="General" sourceLinked="0"/>
-              <c:spPr/>
-              <c:txPr>
-                <a:bodyPr/>
-                <a:lstStyle/>
-                <a:p>
-                  <a:pPr>
-                    <a:defRPr sz="1200" b="0" i="0" u="none" strike="noStrike">
-                      <a:solidFill>
-                        <a:srgbClr val="000000"/>
-                      </a:solidFill>
-                      <a:latin typeface="Arial"/>
-                    </a:defRPr>
-                  </a:pPr>
-                </a:p>
-              </c:txPr>
-              <c:showLegendKey val="0"/>
-              <c:showVal val="0"/>
-              <c:showCatName val="0"/>
-              <c:showSerName val="0"/>
-              <c:showPercent val="0"/>
-              <c:showBubbleSize val="0"/>
-            </c:dLbl>
-            <c:dLbl>
-              <c:idx val="6"/>
-              <c:numFmt formatCode="General" sourceLinked="0"/>
-              <c:spPr/>
-              <c:txPr>
-                <a:bodyPr/>
-                <a:lstStyle/>
-                <a:p>
-                  <a:pPr>
-                    <a:defRPr sz="1200" b="0" i="0" u="none" strike="noStrike">
-                      <a:solidFill>
-                        <a:srgbClr val="000000"/>
-                      </a:solidFill>
-                      <a:latin typeface="Arial"/>
-                    </a:defRPr>
-                  </a:pPr>
-                </a:p>
-              </c:txPr>
-              <c:showLegendKey val="0"/>
-              <c:showVal val="0"/>
-              <c:showCatName val="0"/>
-              <c:showSerName val="0"/>
-              <c:showPercent val="0"/>
-              <c:showBubbleSize val="0"/>
-            </c:dLbl>
-            <c:numFmt formatCode="General" sourceLinked="0"/>
-            <c:txPr>
-              <a:bodyPr/>
-              <a:lstStyle/>
-              <a:p>
-                <a:pPr>
-                  <a:defRPr sz="1800" b="0" i="0" u="none" strike="noStrike">
-                    <a:solidFill>
-                      <a:srgbClr val="000000"/>
-                    </a:solidFill>
-                    <a:latin typeface="Arial"/>
-                  </a:defRPr>
-                </a:pPr>
-              </a:p>
-            </c:txPr>
-            <c:showLegendKey val="0"/>
-            <c:showVal val="0"/>
-            <c:showCatName val="1"/>
-            <c:showSerName val="0"/>
-            <c:showPercent val="1"/>
-            <c:showBubbleSize val="0"/>
-            <c:showLeaderLines val="0"/>
-          </c:dLbls>
-          <c:cat>
-            <c:strRef>
-              <c:f>Sheet1!$A$2:$A$8</c:f>
-              <c:strCache>
-                <c:ptCount val="7"/>
-                <c:pt idx="0">
-                  <c:v>Powertrain</c:v>
-                </c:pt>
-                <c:pt idx="1">
-                  <c:v>HVAC</c:v>
-                </c:pt>
-                <c:pt idx="2">
-                  <c:v>Lighting</c:v>
-                </c:pt>
-                <c:pt idx="3">
-                  <c:v>Electrical</c:v>
-                </c:pt>
-                <c:pt idx="4">
-                  <c:v>Braking</c:v>
-                </c:pt>
-                <c:pt idx="5">
-                  <c:v>Chassis</c:v>
-                </c:pt>
-                <c:pt idx="6">
-                  <c:v>Other</c:v>
-                </c:pt>
-              </c:strCache>
-            </c:strRef>
-          </c:cat>
-          <c:val>
-            <c:numRef>
-              <c:f>Sheet1!$B$2:$B$8</c:f>
-              <c:numCache>
-                <c:ptCount val="7"/>
-                <c:pt idx="0">
-                  <c:v>24.83</c:v>
-                </c:pt>
-                <c:pt idx="1">
-                  <c:v>19.46</c:v>
-                </c:pt>
-                <c:pt idx="2">
-                  <c:v>13.11</c:v>
-                </c:pt>
-                <c:pt idx="3">
-                  <c:v>9.93</c:v>
-                </c:pt>
-                <c:pt idx="4">
-                  <c:v>9.28</c:v>
-                </c:pt>
-                <c:pt idx="5">
-                  <c:v>8.53</c:v>
-                </c:pt>
-                <c:pt idx="6">
-                  <c:v>14.86</c:v>
-                </c:pt>
-              </c:numCache>
-            </c:numRef>
-          </c:val>
-        </c:ser>
-        <c:firstSliceAng val="0"/>
-        <c:holeSize val="58"/>
-      </c:doughnutChart>
-      <c:spPr>
-        <a:noFill/>
-        <a:ln>
-          <a:noFill/>
-        </a:ln>
-        <a:effectLst/>
-      </c:spPr>
-    </c:plotArea>
-    <c:legend>
-      <c:legendPos val="r"/>
-      <c:overlay val="0"/>
-      <c:txPr>
-        <a:bodyPr/>
-        <a:lstStyle/>
-        <a:p>
-          <a:pPr>
-            <a:defRPr sz="1200">
-              <a:solidFill>
-                <a:srgbClr val="1E293B"/>
-              </a:solidFill>
-            </a:defRPr>
-          </a:pPr>
-          <a:endParaRPr lang="en-US"/>
-        </a:p>
-      </c:txPr>
-    </c:legend>
-    <c:plotVisOnly val="1"/>
-    <c:dispBlanksAs val="span"/>
-  </c:chart>
-  <c:spPr>
-    <a:noFill/>
-    <a:ln>
-      <a:noFill/>
-    </a:ln>
-    <a:effectLst/>
-  </c:spPr>
-  <c:externalData r:id="rId1">
-    <c:autoUpdate val="0"/>
-  </c:externalData>
-</c:chartSpace>
-</file>
-
-<file path=ppt/charts/chart4.xml><?xml version="1.0" encoding="utf-8"?>
-<c:chartSpace xmlns:c="http://schemas.openxmlformats.org/drawingml/2006/chart" xmlns:a="http://schemas.openxmlformats.org/drawingml/2006/main" xmlns:r="http://schemas.openxmlformats.org/officeDocument/2006/relationships">
-  <c:date1904 val="0"/>
-  <c:roundedCorners val="1"/>
-  <c:chart>
-    <c:autoTitleDeleted val="1"/>
-    <c:plotArea>
-      <c:layout/>
-      <c:barChart>
-        <c:barDir val="col"/>
-        <c:grouping val="clustered"/>
-        <c:varyColors val="0"/>
-        <c:ser>
-          <c:idx val="0"/>
-          <c:order val="0"/>
-          <c:tx>
-            <c:strRef>
-              <c:f>Sheet1!$B$1</c:f>
-              <c:strCache>
-                <c:ptCount val="1"/>
-                <c:pt idx="0">
-                  <c:v>Basket change %</c:v>
-                </c:pt>
-              </c:strCache>
-            </c:strRef>
-          </c:tx>
-          <c:spPr>
-            <a:solidFill>
-              <a:srgbClr val="2563EB"/>
-            </a:solidFill>
-            <a:effectLst/>
-          </c:spPr>
-          <c:invertIfNegative val="0"/>
-          <c:dLbls>
-            <c:numFmt formatCode="0.00" sourceLinked="0"/>
-            <c:txPr>
-              <a:bodyPr/>
-              <a:lstStyle/>
-              <a:p>
-                <a:pPr>
-                  <a:defRPr b="0" i="0" strike="noStrike" sz="1100" u="none">
-                    <a:solidFill>
-                      <a:srgbClr val="1E293B"/>
-                    </a:solidFill>
-                    <a:latin typeface="Arial"/>
-                  </a:defRPr>
-                </a:pPr>
-              </a:p>
-            </c:txPr>
-            <c:showLegendKey val="0"/>
-            <c:showVal val="1"/>
-            <c:showCatName val="0"/>
-            <c:showSerName val="0"/>
-            <c:showPercent val="0"/>
-            <c:showBubbleSize val="0"/>
-            <c:showLeaderLines val="0"/>
-          </c:dLbls>
-          <c:dPt>
-            <c:idx val="0"/>
-            <c:invertIfNegative val="0"/>
-            <c:bubble3D val="0"/>
-            <c:spPr>
-              <a:solidFill>
-                <a:srgbClr val="16A34A"/>
-              </a:solidFill>
-              <a:effectLst/>
-            </c:spPr>
-          </c:dPt>
-          <c:dPt>
-            <c:idx val="1"/>
-            <c:invertIfNegative val="0"/>
-            <c:bubble3D val="0"/>
-            <c:spPr>
-              <a:solidFill>
-                <a:srgbClr val="16A34A"/>
-              </a:solidFill>
-              <a:effectLst/>
-            </c:spPr>
-          </c:dPt>
-          <c:dPt>
-            <c:idx val="2"/>
-            <c:invertIfNegative val="0"/>
-            <c:bubble3D val="0"/>
-            <c:spPr>
-              <a:solidFill>
-                <a:srgbClr val="16A34A"/>
-              </a:solidFill>
-              <a:effectLst/>
-            </c:spPr>
-          </c:dPt>
-          <c:dPt>
-            <c:idx val="3"/>
-            <c:invertIfNegative val="0"/>
-            <c:bubble3D val="0"/>
-            <c:spPr>
-              <a:solidFill>
-                <a:srgbClr val="2563EB"/>
-              </a:solidFill>
-              <a:effectLst/>
-            </c:spPr>
-          </c:dPt>
-          <c:dPt>
-            <c:idx val="4"/>
-            <c:invertIfNegative val="0"/>
-            <c:bubble3D val="0"/>
-            <c:spPr>
-              <a:solidFill>
-                <a:srgbClr val="2563EB"/>
-              </a:solidFill>
-              <a:effectLst/>
-            </c:spPr>
-          </c:dPt>
-          <c:dPt>
-            <c:idx val="5"/>
-            <c:invertIfNegative val="0"/>
-            <c:bubble3D val="0"/>
-            <c:spPr>
-              <a:solidFill>
-                <a:srgbClr val="2563EB"/>
-              </a:solidFill>
-              <a:effectLst/>
-            </c:spPr>
-          </c:dPt>
-          <c:cat>
-            <c:multiLvlStrRef>
-              <c:f>Sheet1!$A$2:$A$7</c:f>
-              <c:multiLvlStrCache>
-                <c:ptCount val="6"/>
-                <c:lvl>
-                  <c:pt idx="0">
-                    <c:v>-10% FX</c:v>
-                  </c:pt>
-                  <c:pt idx="1">
-                    <c:v>-5% FX</c:v>
-                  </c:pt>
-                  <c:pt idx="2">
-                    <c:v>-2% FX</c:v>
-                  </c:pt>
-                  <c:pt idx="3">
-                    <c:v>+2% FX</c:v>
-                  </c:pt>
-                  <c:pt idx="4">
-                    <c:v>+5% FX</c:v>
-                  </c:pt>
-                  <c:pt idx="5">
-                    <c:v>+10% FX</c:v>
-                  </c:pt>
-                </c:lvl>
-              </c:multiLvlStrCache>
-            </c:multiLvlStrRef>
-          </c:cat>
-          <c:val>
-            <c:numRef>
-              <c:f>Sheet1!$B$2:$B$7</c:f>
-              <c:numCache>
-                <c:formatCode>General</c:formatCode>
-                <c:ptCount val="6"/>
-                <c:pt idx="0">
-                  <c:v>-1.05</c:v>
-                </c:pt>
-                <c:pt idx="1">
-                  <c:v>-0.54</c:v>
-                </c:pt>
-                <c:pt idx="2">
-                  <c:v>-0.22</c:v>
-                </c:pt>
-                <c:pt idx="3">
-                  <c:v>0.84</c:v>
-                </c:pt>
-                <c:pt idx="4">
-                  <c:v>1.31</c:v>
-                </c:pt>
-                <c:pt idx="5">
-                  <c:v>1.57</c:v>
-                </c:pt>
-              </c:numCache>
-            </c:numRef>
-          </c:val>
-        </c:ser>
-        <c:dLbls>
-          <c:numFmt formatCode="0.00" sourceLinked="0"/>
-          <c:txPr>
-            <a:bodyPr/>
-            <a:lstStyle/>
-            <a:p>
-              <a:pPr>
-                <a:defRPr b="0" i="0" strike="noStrike" sz="1100" u="none">
-                  <a:solidFill>
-                    <a:srgbClr val="1E293B"/>
-                  </a:solidFill>
-                  <a:latin typeface="Arial"/>
-                </a:defRPr>
-              </a:pPr>
-            </a:p>
-          </c:txPr>
-          <c:showLegendKey val="0"/>
-          <c:showVal val="1"/>
-          <c:showCatName val="0"/>
-          <c:showSerName val="0"/>
-          <c:showPercent val="0"/>
-          <c:showBubbleSize val="0"/>
-          <c:showLeaderLines val="0"/>
-        </c:dLbls>
-        <c:gapWidth val="150"/>
-        <c:overlap val="0"/>
-        <c:axId val="2094734554"/>
-        <c:axId val="2094734552"/>
-        <c:axId val="2094734556"/>
-      </c:barChart>
-      <c:catAx>
-        <c:axId val="2094734554"/>
-        <c:scaling>
-          <c:orientation val="minMax"/>
-        </c:scaling>
-        <c:delete val="0"/>
-        <c:axPos val="b"/>
-        <c:numFmt formatCode="General" sourceLinked="1"/>
-        <c:majorTickMark val="out"/>
-        <c:minorTickMark val="none"/>
-        <c:tickLblPos val="low"/>
-        <c:spPr>
-          <a:ln w="12700" cap="flat">
-            <a:solidFill>
-              <a:srgbClr val="888888"/>
-            </a:solidFill>
-            <a:prstDash val="solid"/>
-            <a:round/>
-          </a:ln>
-        </c:spPr>
-        <c:txPr>
-          <a:bodyPr/>
-          <a:lstStyle/>
-          <a:p>
-            <a:pPr>
-              <a:defRPr sz="1100" b="0" i="0" u="none" strike="noStrike">
-                <a:solidFill>
-                  <a:srgbClr val="1E293B"/>
-                </a:solidFill>
-                <a:latin typeface="Arial"/>
-              </a:defRPr>
-            </a:pPr>
-            <a:endParaRPr lang="en-US"/>
-          </a:p>
-        </c:txPr>
-        <c:crossAx val="2094734552"/>
-        <c:crosses val="autoZero"/>
-        <c:auto val="1"/>
-        <c:lblAlgn val="ctr"/>
-        <c:noMultiLvlLbl val="1"/>
-      </c:catAx>
-      <c:valAx>
-        <c:axId val="2094734552"/>
-        <c:scaling>
-          <c:orientation val="minMax"/>
-        </c:scaling>
-        <c:delete val="0"/>
-        <c:axPos val="l"/>
-        <c:majorGridlines>
-          <c:spPr>
-            <a:ln w="6350" cap="flat">
-              <a:solidFill>
-                <a:srgbClr val="E2E8F0"/>
-              </a:solidFill>
-              <a:prstDash val="solid"/>
-              <a:round/>
-            </a:ln>
-          </c:spPr>
-        </c:majorGridlines>
-        <c:numFmt formatCode="General" sourceLinked="0"/>
-        <c:majorTickMark val="out"/>
-        <c:minorTickMark val="none"/>
-        <c:tickLblPos val="nextTo"/>
-        <c:spPr>
-          <a:ln w="12700" cap="flat">
-            <a:solidFill>
-              <a:srgbClr val="888888"/>
-            </a:solidFill>
-            <a:prstDash val="solid"/>
-            <a:round/>
-          </a:ln>
-        </c:spPr>
-        <c:txPr>
-          <a:bodyPr/>
-          <a:lstStyle/>
-          <a:p>
-            <a:pPr>
-              <a:defRPr sz="1100" b="0" i="0" u="none" strike="noStrike">
-                <a:solidFill>
-                  <a:srgbClr val="64748B"/>
-                </a:solidFill>
-                <a:latin typeface="Arial"/>
-              </a:defRPr>
-            </a:pPr>
-            <a:endParaRPr lang="en-US"/>
-          </a:p>
-        </c:txPr>
-        <c:crossAx val="2094734554"/>
-        <c:crosses val="autoZero"/>
-        <c:crossBetween val="between"/>
-      </c:valAx>
-      <c:spPr>
-        <a:noFill/>
-        <a:ln>
-          <a:noFill/>
-        </a:ln>
-        <a:effectLst/>
-      </c:spPr>
-    </c:plotArea>
-    <c:plotVisOnly val="1"/>
-    <c:dispBlanksAs val="span"/>
-  </c:chart>
-  <c:spPr>
-    <a:noFill/>
-    <a:ln>
-      <a:noFill/>
-    </a:ln>
-    <a:effectLst/>
-  </c:spPr>
-  <c:externalData r:id="rId1">
-    <c:autoUpdate val="0"/>
-  </c:externalData>
-</c:chartSpace>
-</file>
-
-<file path=ppt/charts/chart5.xml><?xml version="1.0" encoding="utf-8"?>
-<c:chartSpace xmlns:c="http://schemas.openxmlformats.org/drawingml/2006/chart" xmlns:a="http://schemas.openxmlformats.org/drawingml/2006/main" xmlns:r="http://schemas.openxmlformats.org/officeDocument/2006/relationships">
-  <c:date1904 val="0"/>
-  <c:roundedCorners val="1"/>
-  <c:chart>
-    <c:autoTitleDeleted val="1"/>
-    <c:plotArea>
-      <c:layout/>
-      <c:barChart>
-        <c:barDir val="bar"/>
-        <c:grouping val="clustered"/>
-        <c:varyColors val="0"/>
-        <c:ser>
-          <c:idx val="0"/>
-          <c:order val="0"/>
-          <c:tx>
-            <c:strRef>
-              <c:f>Sheet1!$B$1</c:f>
-              <c:strCache>
-                <c:ptCount val="1"/>
-                <c:pt idx="0">
-                  <c:v>Share</c:v>
-                </c:pt>
-              </c:strCache>
-            </c:strRef>
-          </c:tx>
-          <c:spPr>
-            <a:solidFill>
-              <a:srgbClr val="2563EB"/>
-            </a:solidFill>
-            <a:effectLst/>
-          </c:spPr>
-          <c:invertIfNegative val="0"/>
-          <c:dLbls>
-            <c:numFmt formatCode="0.0" sourceLinked="0"/>
-            <c:txPr>
-              <a:bodyPr/>
-              <a:lstStyle/>
-              <a:p>
-                <a:pPr>
-                  <a:defRPr b="0" i="0" strike="noStrike" sz="1100" u="none">
-                    <a:solidFill>
-                      <a:srgbClr val="1E293B"/>
-                    </a:solidFill>
-                    <a:latin typeface="Arial"/>
-                  </a:defRPr>
-                </a:pPr>
-              </a:p>
-            </c:txPr>
-            <c:showLegendKey val="0"/>
-            <c:showVal val="1"/>
-            <c:showCatName val="0"/>
-            <c:showSerName val="0"/>
-            <c:showPercent val="0"/>
-            <c:showBubbleSize val="0"/>
-            <c:showLeaderLines val="0"/>
-          </c:dLbls>
-          <c:cat>
-            <c:multiLvlStrRef>
-              <c:f>Sheet1!$A$2:$A$9</c:f>
-              <c:multiLvlStrCache>
-                <c:ptCount val="8"/>
-                <c:lvl>
-                  <c:pt idx="0">
-                    <c:v>Minda Industries</c:v>
-                  </c:pt>
-                  <c:pt idx="1">
-                    <c:v>Varroc Engineering</c:v>
-                  </c:pt>
-                  <c:pt idx="2">
-                    <c:v>Valeo India</c:v>
-                  </c:pt>
-                  <c:pt idx="3">
-                    <c:v>Bosch India</c:v>
-                  </c:pt>
-                  <c:pt idx="4">
-                    <c:v>Lumax Industries</c:v>
-                  </c:pt>
-                  <c:pt idx="5">
-                    <c:v>Denso India</c:v>
-                  </c:pt>
-                  <c:pt idx="6">
-                    <c:v>Aptiv India</c:v>
-                  </c:pt>
-                  <c:pt idx="7">
-                    <c:v>Others</c:v>
-                  </c:pt>
-                </c:lvl>
-              </c:multiLvlStrCache>
-            </c:multiLvlStrRef>
-          </c:cat>
-          <c:val>
-            <c:numRef>
-              <c:f>Sheet1!$B$2:$B$9</c:f>
-              <c:numCache>
-                <c:formatCode>General</c:formatCode>
-                <c:ptCount val="8"/>
-                <c:pt idx="0">
-                  <c:v>23.6</c:v>
-                </c:pt>
-                <c:pt idx="1">
-                  <c:v>15</c:v>
-                </c:pt>
-                <c:pt idx="2">
-                  <c:v>12.1</c:v>
-                </c:pt>
-                <c:pt idx="3">
-                  <c:v>11.5</c:v>
-                </c:pt>
-                <c:pt idx="4">
-                  <c:v>11.3</c:v>
-                </c:pt>
-                <c:pt idx="5">
-                  <c:v>8.6</c:v>
-                </c:pt>
-                <c:pt idx="6">
-                  <c:v>7.6</c:v>
-                </c:pt>
-                <c:pt idx="7">
-                  <c:v>10.4</c:v>
-                </c:pt>
-              </c:numCache>
-            </c:numRef>
-          </c:val>
-        </c:ser>
-        <c:dLbls>
-          <c:numFmt formatCode="0.0" sourceLinked="0"/>
-          <c:txPr>
-            <a:bodyPr/>
-            <a:lstStyle/>
-            <a:p>
-              <a:pPr>
-                <a:defRPr b="0" i="0" strike="noStrike" sz="1100" u="none">
-                  <a:solidFill>
-                    <a:srgbClr val="1E293B"/>
-                  </a:solidFill>
-                  <a:latin typeface="Arial"/>
-                </a:defRPr>
-              </a:pPr>
-            </a:p>
-          </c:txPr>
-          <c:showLegendKey val="0"/>
-          <c:showVal val="1"/>
-          <c:showCatName val="0"/>
-          <c:showSerName val="0"/>
-          <c:showPercent val="0"/>
-          <c:showBubbleSize val="0"/>
-          <c:showLeaderLines val="0"/>
-        </c:dLbls>
-        <c:gapWidth val="150"/>
-        <c:overlap val="0"/>
-        <c:axId val="2094734554"/>
-        <c:axId val="2094734552"/>
-        <c:axId val="2094734556"/>
-      </c:barChart>
-      <c:catAx>
-        <c:axId val="2094734554"/>
-        <c:scaling>
-          <c:orientation val="maxMin"/>
-        </c:scaling>
-        <c:delete val="0"/>
-        <c:axPos val="l"/>
-        <c:numFmt formatCode="General" sourceLinked="1"/>
-        <c:majorTickMark val="out"/>
-        <c:minorTickMark val="none"/>
-        <c:tickLblPos val="nextTo"/>
-        <c:spPr>
-          <a:ln w="12700" cap="flat">
-            <a:solidFill>
-              <a:srgbClr val="888888"/>
-            </a:solidFill>
-            <a:prstDash val="solid"/>
-            <a:round/>
-          </a:ln>
-        </c:spPr>
-        <c:txPr>
-          <a:bodyPr/>
-          <a:lstStyle/>
-          <a:p>
-            <a:pPr>
-              <a:defRPr sz="1100" b="0" i="0" u="none" strike="noStrike">
-                <a:solidFill>
-                  <a:srgbClr val="1E293B"/>
-                </a:solidFill>
-                <a:latin typeface="Arial"/>
-              </a:defRPr>
-            </a:pPr>
-            <a:endParaRPr lang="en-US"/>
-          </a:p>
-        </c:txPr>
-        <c:crossAx val="2094734552"/>
-        <c:crosses val="autoZero"/>
-        <c:auto val="1"/>
-        <c:lblAlgn val="ctr"/>
-        <c:noMultiLvlLbl val="1"/>
-      </c:catAx>
-      <c:valAx>
-        <c:axId val="2094734552"/>
-        <c:scaling>
-          <c:orientation val="minMax"/>
-        </c:scaling>
-        <c:delete val="1"/>
-        <c:axPos val="b"/>
-        <c:majorGridlines>
-          <c:spPr>
-            <a:ln w="6350" cap="flat">
-              <a:solidFill>
-                <a:srgbClr val="E2E8F0"/>
-              </a:solidFill>
-              <a:prstDash val="solid"/>
-              <a:round/>
-            </a:ln>
-          </c:spPr>
-        </c:majorGridlines>
-        <c:numFmt formatCode="General" sourceLinked="0"/>
-        <c:majorTickMark val="out"/>
-        <c:minorTickMark val="none"/>
-        <c:tickLblPos val="low"/>
-        <c:spPr>
-          <a:ln w="12700" cap="flat">
-            <a:solidFill>
-              <a:srgbClr val="888888"/>
-            </a:solidFill>
-            <a:prstDash val="solid"/>
-            <a:round/>
-          </a:ln>
-        </c:spPr>
-        <c:txPr>
-          <a:bodyPr/>
-          <a:lstStyle/>
-          <a:p>
-            <a:pPr>
-              <a:defRPr sz="1100" b="0" i="0" u="none" strike="noStrike">
-                <a:solidFill>
-                  <a:srgbClr val="64748B"/>
-                </a:solidFill>
-                <a:latin typeface="Arial"/>
-              </a:defRPr>
-            </a:pPr>
-            <a:endParaRPr lang="en-US"/>
-          </a:p>
-        </c:txPr>
-        <c:crossAx val="2094734554"/>
-        <c:crosses val="autoZero"/>
-        <c:crossBetween val="between"/>
-      </c:valAx>
-      <c:spPr>
-        <a:noFill/>
-        <a:ln>
-          <a:noFill/>
-        </a:ln>
-        <a:effectLst/>
-      </c:spPr>
-    </c:plotArea>
-    <c:plotVisOnly val="1"/>
-    <c:dispBlanksAs val="span"/>
-  </c:chart>
-  <c:spPr>
-    <a:noFill/>
-    <a:ln>
-      <a:noFill/>
-    </a:ln>
-    <a:effectLst/>
-  </c:spPr>
-  <c:externalData r:id="rId1">
-    <c:autoUpdate val="0"/>
-  </c:externalData>
-</c:chartSpace>
 </file>
 
 <file path=ppt/notesMasters/notesMaster1.xml><?xml version="1.0" encoding="utf-8"?>
@@ -4175,7 +2446,7 @@
                 <a:ea typeface="Cambria" pitchFamily="34" charset="-122"/>
                 <a:cs typeface="Cambria" pitchFamily="34" charset="-120"/>
               </a:rPr>
-              <a:t>₹17.56 L</a:t>
+              <a:t>â‚¹17.56 L</a:t>
             </a:r>
             <a:endParaRPr lang="en-US" sz="2800" dirty="0"/>
           </a:p>
@@ -4319,7 +2590,7 @@
                 <a:ea typeface="Cambria" pitchFamily="34" charset="-122"/>
                 <a:cs typeface="Cambria" pitchFamily="34" charset="-120"/>
               </a:rPr>
-              <a:t>₹17.78 L</a:t>
+              <a:t>â‚¹17.78 L</a:t>
             </a:r>
             <a:endParaRPr lang="en-US" sz="2800" dirty="0"/>
           </a:p>
@@ -4607,7 +2878,7 @@
                 <a:ea typeface="Cambria" pitchFamily="34" charset="-122"/>
                 <a:cs typeface="Cambria" pitchFamily="34" charset="-120"/>
               </a:rPr>
-              <a:t>₹2.83 L</a:t>
+              <a:t>â‚¹2.83 L</a:t>
             </a:r>
             <a:endParaRPr lang="en-US" sz="2800" dirty="0"/>
           </a:p>
@@ -4834,28 +3105,36 @@
                 <a:ea typeface="Calibri" pitchFamily="34" charset="-122"/>
                 <a:cs typeface="Calibri" pitchFamily="34" charset="-120"/>
               </a:rPr>
-              <a:t>Forecast basket price, Jul to Dec 2026 (₹ lakh)</a:t>
+              <a:t>Forecast basket price, Jul to Dec 2026 (â‚¹ lakh)</a:t>
             </a:r>
             <a:endParaRPr lang="en-US" sz="1400" dirty="0"/>
           </a:p>
         </p:txBody>
       </p:sp>
-      <p:graphicFrame>
-        <p:nvGraphicFramePr>
-          <p:cNvPr id="4" name="Chart 0" descr=""/>
-          <p:cNvGraphicFramePr/>
-          <p:nvPr/>
-        </p:nvGraphicFramePr>
-        <p:xfrm>
-          <a:off x="548640" y="1463040"/>
-          <a:ext cx="5303520" cy="3200400"/>
-        </p:xfrm>
-        <a:graphic xmlns:a="http://schemas.openxmlformats.org/drawingml/2006/main">
-          <a:graphicData uri="http://schemas.openxmlformats.org/drawingml/2006/chart">
-            <c:chart xmlns:c="http://schemas.openxmlformats.org/drawingml/2006/chart" r:id="rId1"/>
-          </a:graphicData>
-        </a:graphic>
-      </p:graphicFrame>
+      <p:pic>
+        <p:nvPicPr>
+          <p:cNvPr id="4" name="Image 0" descr="chart">    </p:cNvPr>
+          <p:cNvPicPr>
+            <a:picLocks noChangeAspect="1"/>
+          </p:cNvPicPr>
+          <p:nvPr/>
+        </p:nvPicPr>
+        <p:blipFill>
+          <a:blip r:embed="rId1"/>
+          <a:stretch>
+            <a:fillRect/>
+          </a:stretch>
+        </p:blipFill>
+        <p:spPr>
+          <a:xfrm>
+            <a:off x="548640" y="1463040"/>
+            <a:ext cx="5303520" cy="3200400"/>
+          </a:xfrm>
+          <a:prstGeom prst="rect">
+            <a:avLst/>
+          </a:prstGeom>
+        </p:spPr>
+      </p:pic>
       <p:sp>
         <p:nvSpPr>
           <p:cNvPr id="5" name="Shape 2"/>
@@ -4936,7 +3215,7 @@
                 <a:ea typeface="Calibri" pitchFamily="34" charset="-122"/>
                 <a:cs typeface="Calibri" pitchFamily="34" charset="-120"/>
               </a:rPr>
-              <a:t>Peak at ₹17.93 L in October, up 1.2% from July.</a:t>
+              <a:t>Peak at â‚¹17.93 L in October, up 1.2% from July.</a:t>
             </a:r>
             <a:endParaRPr lang="en-US" sz="1400" dirty="0"/>
           </a:p>
@@ -4956,7 +3235,7 @@
                 <a:ea typeface="Calibri" pitchFamily="34" charset="-122"/>
                 <a:cs typeface="Calibri" pitchFamily="34" charset="-120"/>
               </a:rPr>
-              <a:t>Confidence band widens to ±₹0.7 L by August.</a:t>
+              <a:t>Confidence band widens to Â±â‚¹0.7 L by August.</a:t>
             </a:r>
             <a:endParaRPr lang="en-US" sz="1400" dirty="0"/>
           </a:p>
@@ -5128,22 +3407,30 @@
           </a:p>
         </p:txBody>
       </p:sp>
-      <p:graphicFrame>
-        <p:nvGraphicFramePr>
-          <p:cNvPr id="4" name="Chart 0" descr=""/>
-          <p:cNvGraphicFramePr/>
-          <p:nvPr/>
-        </p:nvGraphicFramePr>
-        <p:xfrm>
-          <a:off x="548640" y="1417320"/>
-          <a:ext cx="8046720" cy="3246120"/>
-        </p:xfrm>
-        <a:graphic xmlns:a="http://schemas.openxmlformats.org/drawingml/2006/main">
-          <a:graphicData uri="http://schemas.openxmlformats.org/drawingml/2006/chart">
-            <c:chart xmlns:c="http://schemas.openxmlformats.org/drawingml/2006/chart" r:id="rId1"/>
-          </a:graphicData>
-        </a:graphic>
-      </p:graphicFrame>
+      <p:pic>
+        <p:nvPicPr>
+          <p:cNvPr id="4" name="Image 0" descr="chart">    </p:cNvPr>
+          <p:cNvPicPr>
+            <a:picLocks noChangeAspect="1"/>
+          </p:cNvPicPr>
+          <p:nvPr/>
+        </p:nvPicPr>
+        <p:blipFill>
+          <a:blip r:embed="rId1"/>
+          <a:stretch>
+            <a:fillRect/>
+          </a:stretch>
+        </p:blipFill>
+        <p:spPr>
+          <a:xfrm>
+            <a:off x="548640" y="1417320"/>
+            <a:ext cx="8046720" cy="3246120"/>
+          </a:xfrm>
+          <a:prstGeom prst="rect">
+            <a:avLst/>
+          </a:prstGeom>
+        </p:spPr>
+      </p:pic>
       <p:sp>
         <p:nvSpPr>
           <p:cNvPr id="5" name="Text 2"/>
@@ -5293,22 +3580,30 @@
           </a:p>
         </p:txBody>
       </p:sp>
-      <p:graphicFrame>
-        <p:nvGraphicFramePr>
-          <p:cNvPr id="4" name="Chart 0" descr=""/>
-          <p:cNvGraphicFramePr/>
-          <p:nvPr/>
-        </p:nvGraphicFramePr>
-        <p:xfrm>
-          <a:off x="548640" y="1417320"/>
-          <a:ext cx="4937760" cy="3246120"/>
-        </p:xfrm>
-        <a:graphic xmlns:a="http://schemas.openxmlformats.org/drawingml/2006/main">
-          <a:graphicData uri="http://schemas.openxmlformats.org/drawingml/2006/chart">
-            <c:chart xmlns:c="http://schemas.openxmlformats.org/drawingml/2006/chart" r:id="rId1"/>
-          </a:graphicData>
-        </a:graphic>
-      </p:graphicFrame>
+      <p:pic>
+        <p:nvPicPr>
+          <p:cNvPr id="4" name="Image 0" descr="chart">    </p:cNvPr>
+          <p:cNvPicPr>
+            <a:picLocks noChangeAspect="1"/>
+          </p:cNvPicPr>
+          <p:nvPr/>
+        </p:nvPicPr>
+        <p:blipFill>
+          <a:blip r:embed="rId1"/>
+          <a:stretch>
+            <a:fillRect/>
+          </a:stretch>
+        </p:blipFill>
+        <p:spPr>
+          <a:xfrm>
+            <a:off x="548640" y="1417320"/>
+            <a:ext cx="4937760" cy="3246120"/>
+          </a:xfrm>
+          <a:prstGeom prst="rect">
+            <a:avLst/>
+          </a:prstGeom>
+        </p:spPr>
+      </p:pic>
       <p:sp>
         <p:nvSpPr>
           <p:cNvPr id="5" name="Shape 2"/>
@@ -6116,22 +4411,30 @@
           </a:p>
         </p:txBody>
       </p:sp>
-      <p:graphicFrame>
-        <p:nvGraphicFramePr>
-          <p:cNvPr id="4" name="Chart 0" descr=""/>
-          <p:cNvGraphicFramePr/>
-          <p:nvPr/>
-        </p:nvGraphicFramePr>
-        <p:xfrm>
-          <a:off x="548640" y="1417320"/>
-          <a:ext cx="8046720" cy="3246120"/>
-        </p:xfrm>
-        <a:graphic xmlns:a="http://schemas.openxmlformats.org/drawingml/2006/main">
-          <a:graphicData uri="http://schemas.openxmlformats.org/drawingml/2006/chart">
-            <c:chart xmlns:c="http://schemas.openxmlformats.org/drawingml/2006/chart" r:id="rId1"/>
-          </a:graphicData>
-        </a:graphic>
-      </p:graphicFrame>
+      <p:pic>
+        <p:nvPicPr>
+          <p:cNvPr id="4" name="Image 0" descr="chart">    </p:cNvPr>
+          <p:cNvPicPr>
+            <a:picLocks noChangeAspect="1"/>
+          </p:cNvPicPr>
+          <p:nvPr/>
+        </p:nvPicPr>
+        <p:blipFill>
+          <a:blip r:embed="rId1"/>
+          <a:stretch>
+            <a:fillRect/>
+          </a:stretch>
+        </p:blipFill>
+        <p:spPr>
+          <a:xfrm>
+            <a:off x="548640" y="1417320"/>
+            <a:ext cx="8046720" cy="3246120"/>
+          </a:xfrm>
+          <a:prstGeom prst="rect">
+            <a:avLst/>
+          </a:prstGeom>
+        </p:spPr>
+      </p:pic>
       <p:sp>
         <p:nvSpPr>
           <p:cNvPr id="5" name="Text 2"/>
@@ -6281,22 +4584,30 @@
           </a:p>
         </p:txBody>
       </p:sp>
-      <p:graphicFrame>
-        <p:nvGraphicFramePr>
-          <p:cNvPr id="4" name="Chart 0" descr=""/>
-          <p:cNvGraphicFramePr/>
-          <p:nvPr/>
-        </p:nvGraphicFramePr>
-        <p:xfrm>
-          <a:off x="548640" y="1417320"/>
-          <a:ext cx="8046720" cy="3246120"/>
-        </p:xfrm>
-        <a:graphic xmlns:a="http://schemas.openxmlformats.org/drawingml/2006/main">
-          <a:graphicData uri="http://schemas.openxmlformats.org/drawingml/2006/chart">
-            <c:chart xmlns:c="http://schemas.openxmlformats.org/drawingml/2006/chart" r:id="rId1"/>
-          </a:graphicData>
-        </a:graphic>
-      </p:graphicFrame>
+      <p:pic>
+        <p:nvPicPr>
+          <p:cNvPr id="4" name="Image 0" descr="chart">    </p:cNvPr>
+          <p:cNvPicPr>
+            <a:picLocks noChangeAspect="1"/>
+          </p:cNvPicPr>
+          <p:nvPr/>
+        </p:nvPicPr>
+        <p:blipFill>
+          <a:blip r:embed="rId1"/>
+          <a:stretch>
+            <a:fillRect/>
+          </a:stretch>
+        </p:blipFill>
+        <p:spPr>
+          <a:xfrm>
+            <a:off x="548640" y="1417320"/>
+            <a:ext cx="8046720" cy="3246120"/>
+          </a:xfrm>
+          <a:prstGeom prst="rect">
+            <a:avLst/>
+          </a:prstGeom>
+        </p:spPr>
+      </p:pic>
       <p:sp>
         <p:nvSpPr>
           <p:cNvPr id="5" name="Text 2"/>

</xml_diff>

<commit_message>
Show buyer-friendly part names and rupee prices in the drill-down and forecast chart, add market and material context so the Why answer reads like real procurement commentary, and refresh the sample PPT report.
</commit_message>
<xml_diff>
--- a/dashboard/public/reports/Auto_Parts_Price_Outlook.pptx
+++ b/dashboard/public/reports/Auto_Parts_Price_Outlook.pptx
@@ -2333,7 +2333,7 @@
               <a:buNone/>
             </a:pPr>
             <a:r>
-              <a:rPr lang="en-US" sz="3000" b="1" dirty="0">
+              <a:rPr lang="en-US" sz="2800" b="1" dirty="0">
                 <a:solidFill>
                   <a:srgbClr val="0B1F3A"/>
                 </a:solidFill>
@@ -2341,9 +2341,9 @@
                 <a:ea typeface="Cambria" pitchFamily="34" charset="-122"/>
                 <a:cs typeface="Cambria" pitchFamily="34" charset="-120"/>
               </a:rPr>
-              <a:t>Basket edges up 1.3%, but risk is concentrated</a:t>
-            </a:r>
-            <a:endParaRPr lang="en-US" sz="3000" dirty="0"/>
+              <a:t>Basket up 1.3%, risk is concentrated</a:t>
+            </a:r>
+            <a:endParaRPr lang="en-US" sz="2800" dirty="0"/>
           </a:p>
         </p:txBody>
       </p:sp>
@@ -2422,7 +2422,7 @@
         <p:spPr>
           <a:xfrm>
             <a:off x="685800" y="1828800"/>
-            <a:ext cx="1600200" cy="640080"/>
+            <a:ext cx="1691640" cy="640080"/>
           </a:xfrm>
           <a:prstGeom prst="rect">
             <a:avLst/>
@@ -2438,7 +2438,7 @@
               <a:buNone/>
             </a:pPr>
             <a:r>
-              <a:rPr lang="en-US" sz="2800" b="1" dirty="0">
+              <a:rPr lang="en-US" sz="2400" b="1" dirty="0">
                 <a:solidFill>
                   <a:srgbClr val="0B1F3A"/>
                 </a:solidFill>
@@ -2446,9 +2446,9 @@
                 <a:ea typeface="Cambria" pitchFamily="34" charset="-122"/>
                 <a:cs typeface="Cambria" pitchFamily="34" charset="-120"/>
               </a:rPr>
-              <a:t>â‚¹17.56 L</a:t>
-            </a:r>
-            <a:endParaRPr lang="en-US" sz="2800" dirty="0"/>
+              <a:t>₹17.56 L</a:t>
+            </a:r>
+            <a:endParaRPr lang="en-US" sz="2400" dirty="0"/>
           </a:p>
         </p:txBody>
       </p:sp>
@@ -2566,7 +2566,7 @@
         <p:spPr>
           <a:xfrm>
             <a:off x="2743200" y="1828800"/>
-            <a:ext cx="1600200" cy="640080"/>
+            <a:ext cx="1691640" cy="640080"/>
           </a:xfrm>
           <a:prstGeom prst="rect">
             <a:avLst/>
@@ -2582,7 +2582,7 @@
               <a:buNone/>
             </a:pPr>
             <a:r>
-              <a:rPr lang="en-US" sz="2800" b="1" dirty="0">
+              <a:rPr lang="en-US" sz="2400" b="1" dirty="0">
                 <a:solidFill>
                   <a:srgbClr val="0B1F3A"/>
                 </a:solidFill>
@@ -2590,9 +2590,9 @@
                 <a:ea typeface="Cambria" pitchFamily="34" charset="-122"/>
                 <a:cs typeface="Cambria" pitchFamily="34" charset="-120"/>
               </a:rPr>
-              <a:t>â‚¹17.78 L</a:t>
-            </a:r>
-            <a:endParaRPr lang="en-US" sz="2800" dirty="0"/>
+              <a:t>₹17.78 L</a:t>
+            </a:r>
+            <a:endParaRPr lang="en-US" sz="2400" dirty="0"/>
           </a:p>
         </p:txBody>
       </p:sp>
@@ -2710,7 +2710,7 @@
         <p:spPr>
           <a:xfrm>
             <a:off x="4800600" y="1828800"/>
-            <a:ext cx="1600200" cy="640080"/>
+            <a:ext cx="1691640" cy="640080"/>
           </a:xfrm>
           <a:prstGeom prst="rect">
             <a:avLst/>
@@ -2726,7 +2726,7 @@
               <a:buNone/>
             </a:pPr>
             <a:r>
-              <a:rPr lang="en-US" sz="2800" b="1" dirty="0">
+              <a:rPr lang="en-US" sz="2400" b="1" dirty="0">
                 <a:solidFill>
                   <a:srgbClr val="0B1F3A"/>
                 </a:solidFill>
@@ -2736,7 +2736,7 @@
               </a:rPr>
               <a:t>96.7%</a:t>
             </a:r>
-            <a:endParaRPr lang="en-US" sz="2800" dirty="0"/>
+            <a:endParaRPr lang="en-US" sz="2400" dirty="0"/>
           </a:p>
         </p:txBody>
       </p:sp>
@@ -2854,7 +2854,7 @@
         <p:spPr>
           <a:xfrm>
             <a:off x="6858000" y="1828800"/>
-            <a:ext cx="1600200" cy="640080"/>
+            <a:ext cx="1691640" cy="640080"/>
           </a:xfrm>
           <a:prstGeom prst="rect">
             <a:avLst/>
@@ -2870,7 +2870,7 @@
               <a:buNone/>
             </a:pPr>
             <a:r>
-              <a:rPr lang="en-US" sz="2800" b="1" dirty="0">
+              <a:rPr lang="en-US" sz="2400" b="1" dirty="0">
                 <a:solidFill>
                   <a:srgbClr val="0B1F3A"/>
                 </a:solidFill>
@@ -2878,9 +2878,9 @@
                 <a:ea typeface="Cambria" pitchFamily="34" charset="-122"/>
                 <a:cs typeface="Cambria" pitchFamily="34" charset="-120"/>
               </a:rPr>
-              <a:t>â‚¹2.83 L</a:t>
-            </a:r>
-            <a:endParaRPr lang="en-US" sz="2800" dirty="0"/>
+              <a:t>₹2.83 L</a:t>
+            </a:r>
+            <a:endParaRPr lang="en-US" sz="2400" dirty="0"/>
           </a:p>
         </p:txBody>
       </p:sp>
@@ -3058,7 +3058,7 @@
               <a:buNone/>
             </a:pPr>
             <a:r>
-              <a:rPr lang="en-US" sz="3000" b="1" dirty="0">
+              <a:rPr lang="en-US" sz="2800" b="1" dirty="0">
                 <a:solidFill>
                   <a:srgbClr val="0B1F3A"/>
                 </a:solidFill>
@@ -3068,7 +3068,7 @@
               </a:rPr>
               <a:t>Prices climb through October, then ease</a:t>
             </a:r>
-            <a:endParaRPr lang="en-US" sz="3000" dirty="0"/>
+            <a:endParaRPr lang="en-US" sz="2800" dirty="0"/>
           </a:p>
         </p:txBody>
       </p:sp>
@@ -3105,7 +3105,7 @@
                 <a:ea typeface="Calibri" pitchFamily="34" charset="-122"/>
                 <a:cs typeface="Calibri" pitchFamily="34" charset="-120"/>
               </a:rPr>
-              <a:t>Forecast basket price, Jul to Dec 2026 (â‚¹ lakh)</a:t>
+              <a:t>Forecast basket price, Jul to Dec 2026 (₹ lakh)</a:t>
             </a:r>
             <a:endParaRPr lang="en-US" sz="1400" dirty="0"/>
           </a:p>
@@ -3215,7 +3215,7 @@
                 <a:ea typeface="Calibri" pitchFamily="34" charset="-122"/>
                 <a:cs typeface="Calibri" pitchFamily="34" charset="-120"/>
               </a:rPr>
-              <a:t>Peak at â‚¹17.93 L in October, up 1.2% from July.</a:t>
+              <a:t>Peak at ₹17.93 L in October, up 1.2% from July.</a:t>
             </a:r>
             <a:endParaRPr lang="en-US" sz="1400" dirty="0"/>
           </a:p>
@@ -3235,7 +3235,7 @@
                 <a:ea typeface="Calibri" pitchFamily="34" charset="-122"/>
                 <a:cs typeface="Calibri" pitchFamily="34" charset="-120"/>
               </a:rPr>
-              <a:t>Confidence band widens to Â±â‚¹0.7 L by August.</a:t>
+              <a:t>Confidence band widens to ±₹0.7 L by August.</a:t>
             </a:r>
             <a:endParaRPr lang="en-US" sz="1400" dirty="0"/>
           </a:p>
@@ -3354,7 +3354,7 @@
               <a:buNone/>
             </a:pPr>
             <a:r>
-              <a:rPr lang="en-US" sz="3000" b="1" dirty="0">
+              <a:rPr lang="en-US" sz="2800" b="1" dirty="0">
                 <a:solidFill>
                   <a:srgbClr val="0B1F3A"/>
                 </a:solidFill>
@@ -3362,9 +3362,9 @@
                 <a:ea typeface="Cambria" pitchFamily="34" charset="-122"/>
                 <a:cs typeface="Cambria" pitchFamily="34" charset="-120"/>
               </a:rPr>
-              <a:t>Electrical and Lighting see the sharpest rises</a:t>
-            </a:r>
-            <a:endParaRPr lang="en-US" sz="3000" dirty="0"/>
+              <a:t>Electrical and Lighting rise the most</a:t>
+            </a:r>
+            <a:endParaRPr lang="en-US" sz="2800" dirty="0"/>
           </a:p>
         </p:txBody>
       </p:sp>
@@ -3527,7 +3527,7 @@
               <a:buNone/>
             </a:pPr>
             <a:r>
-              <a:rPr lang="en-US" sz="3000" b="1" dirty="0">
+              <a:rPr lang="en-US" sz="2800" b="1" dirty="0">
                 <a:solidFill>
                   <a:srgbClr val="0B1F3A"/>
                 </a:solidFill>
@@ -3537,7 +3537,7 @@
               </a:rPr>
               <a:t>Powertrain and HVAC carry 44% of spend</a:t>
             </a:r>
-            <a:endParaRPr lang="en-US" sz="3000" dirty="0"/>
+            <a:endParaRPr lang="en-US" sz="2800" dirty="0"/>
           </a:p>
         </p:txBody>
       </p:sp>
@@ -3783,7 +3783,7 @@
               <a:buNone/>
             </a:pPr>
             <a:r>
-              <a:rPr lang="en-US" sz="3000" b="1" dirty="0">
+              <a:rPr lang="en-US" sz="2800" b="1" dirty="0">
                 <a:solidFill>
                   <a:srgbClr val="0B1F3A"/>
                 </a:solidFill>
@@ -3793,7 +3793,7 @@
               </a:rPr>
               <a:t>Three drivers explain the move</a:t>
             </a:r>
-            <a:endParaRPr lang="en-US" sz="3000" dirty="0"/>
+            <a:endParaRPr lang="en-US" sz="2800" dirty="0"/>
           </a:p>
         </p:txBody>
       </p:sp>
@@ -4358,7 +4358,7 @@
               <a:buNone/>
             </a:pPr>
             <a:r>
-              <a:rPr lang="en-US" sz="3000" b="1" dirty="0">
+              <a:rPr lang="en-US" sz="2800" b="1" dirty="0">
                 <a:solidFill>
                   <a:srgbClr val="0B1F3A"/>
                 </a:solidFill>
@@ -4368,7 +4368,7 @@
               </a:rPr>
               <a:t>FX swings move the basket by up to 1.6%</a:t>
             </a:r>
-            <a:endParaRPr lang="en-US" sz="3000" dirty="0"/>
+            <a:endParaRPr lang="en-US" sz="2800" dirty="0"/>
           </a:p>
         </p:txBody>
       </p:sp>
@@ -4531,7 +4531,7 @@
               <a:buNone/>
             </a:pPr>
             <a:r>
-              <a:rPr lang="en-US" sz="3000" b="1" dirty="0">
+              <a:rPr lang="en-US" sz="2800" b="1" dirty="0">
                 <a:solidFill>
                   <a:srgbClr val="0B1F3A"/>
                 </a:solidFill>
@@ -4539,9 +4539,9 @@
                 <a:ea typeface="Cambria" pitchFamily="34" charset="-122"/>
                 <a:cs typeface="Cambria" pitchFamily="34" charset="-120"/>
               </a:rPr>
-              <a:t>Minda alone holds nearly a quarter of the risk</a:t>
-            </a:r>
-            <a:endParaRPr lang="en-US" sz="3000" dirty="0"/>
+              <a:t>Minda holds a quarter of the risk</a:t>
+            </a:r>
+            <a:endParaRPr lang="en-US" sz="2800" dirty="0"/>
           </a:p>
         </p:txBody>
       </p:sp>
@@ -4704,7 +4704,7 @@
               <a:buNone/>
             </a:pPr>
             <a:r>
-              <a:rPr lang="en-US" sz="3000" b="1" dirty="0">
+              <a:rPr lang="en-US" sz="2800" b="1" dirty="0">
                 <a:solidFill>
                   <a:srgbClr val="0B1F3A"/>
                 </a:solidFill>
@@ -4714,7 +4714,7 @@
               </a:rPr>
               <a:t>Four vendors hold 62% of the risk</a:t>
             </a:r>
-            <a:endParaRPr lang="en-US" sz="3000" dirty="0"/>
+            <a:endParaRPr lang="en-US" sz="2800" dirty="0"/>
           </a:p>
         </p:txBody>
       </p:sp>

</xml_diff>